<commit_message>
Bring the deck and the test-plan note up to the 19 October fixes
The commits of 19 October closed `DEF-14` - `affectsCharge` now decides at `N_CL_ChargeImpactDecision`
- and added the fourth record of 15 October. The deck and one paragraph of the test plan still read
as they did before: slide 8 listed the DEF-14 condition as still open, slide 11 listed it under
"what is not done", and the references counted three records of 15 October. The deck generator is
corrected and the deck regenerated.

The test plan's note on the `57b3c1d` re-run said `TC-13` and `TC-16` had never been run and that
`DEF-14` was still intent rather than a guard, in the present tense. It now says what that run did
not cover and where each item stands - the scenarios were driven on 15 October, and the condition
now decides at a gateway - rather than presenting the position of 28 September as current. The Word
rendering and the copies in `submission/` are refreshed with it.
</commit_message>
<xml_diff>
--- a/HPRTAS - Second Release.pptx
+++ b/HPRTAS - Second Release.pptx
@@ -4294,7 +4294,7 @@
         </p:nvGraphicFramePr>
         <p:xfrm>
           <a:off x="566928" y="1024128"/>
-          <a:ext cx="11064240" cy="5486400"/>
+          <a:ext cx="11064240" cy="4572000"/>
         </p:xfrm>
         <a:graphic>
           <a:graphicData uri="http://schemas.openxmlformats.org/drawingml/2006/table">
@@ -4657,7 +4657,7 @@
                           </a:solidFill>
                           <a:latin typeface="Segoe UI"/>
                         </a:rPr>
-                        <a:t>affectsCharge as a guard</a:t>
+                        <a:t>GP registry validation; multi-instance cardinality; a GP-side rejection</a:t>
                       </a:r>
                     </a:p>
                   </a:txBody>
@@ -4684,7 +4684,7 @@
                           </a:solidFill>
                           <a:latin typeface="Segoe UI"/>
                         </a:rPr>
-                        <a:t>A condition on an activity's only outgoing flow is never evaluated by Camunda; enforcing it needs a gateway</a:t>
+                        <a:t>Decisions not to adopt, each with its reason: there is no primary-care registry in the case, no user task iterates a collection, and the case gives the clinical decision to the hospital</a:t>
                       </a:r>
                     </a:p>
                   </a:txBody>
@@ -4711,96 +4711,13 @@
                           </a:solidFill>
                           <a:latin typeface="Segoe UI"/>
                         </a:rPr>
-                        <a:t>DEF-14</a:t>
+                        <a:t>docs/agile/response-to-feedback.md</a:t>
                       </a:r>
                     </a:p>
                   </a:txBody>
                   <a:tcPr marL="64008" marR="45720" marT="18288" marB="18288" anchor="t">
                     <a:solidFill>
                       <a:srgbClr val="F4F7F9"/>
-                    </a:solidFill>
-                  </a:tcPr>
-                </a:tc>
-              </a:tr>
-              <a:tr h="914400">
-                <a:tc>
-                  <a:txBody>
-                    <a:bodyPr wrap="square"/>
-                    <a:lstStyle/>
-                    <a:p>
-                      <a:pPr>
-                        <a:spcAft>
-                          <a:spcPts val="0"/>
-                        </a:spcAft>
-                      </a:pPr>
-                      <a:r>
-                        <a:rPr sz="950" b="0">
-                          <a:solidFill>
-                            <a:srgbClr val="535F6B"/>
-                          </a:solidFill>
-                          <a:latin typeface="Segoe UI"/>
-                        </a:rPr>
-                        <a:t>GP registry validation; multi-instance cardinality; a GP-side rejection</a:t>
-                      </a:r>
-                    </a:p>
-                  </a:txBody>
-                  <a:tcPr marL="64008" marR="45720" marT="18288" marB="18288" anchor="t">
-                    <a:solidFill>
-                      <a:srgbClr val="FFFFFF"/>
-                    </a:solidFill>
-                  </a:tcPr>
-                </a:tc>
-                <a:tc>
-                  <a:txBody>
-                    <a:bodyPr wrap="square"/>
-                    <a:lstStyle/>
-                    <a:p>
-                      <a:pPr>
-                        <a:spcAft>
-                          <a:spcPts val="0"/>
-                        </a:spcAft>
-                      </a:pPr>
-                      <a:r>
-                        <a:rPr sz="950" b="0">
-                          <a:solidFill>
-                            <a:srgbClr val="535F6B"/>
-                          </a:solidFill>
-                          <a:latin typeface="Segoe UI"/>
-                        </a:rPr>
-                        <a:t>Decisions not to adopt, each with its reason: there is no primary-care registry in the case, no user task iterates a collection, and the case gives the clinical decision to the hospital</a:t>
-                      </a:r>
-                    </a:p>
-                  </a:txBody>
-                  <a:tcPr marL="64008" marR="45720" marT="18288" marB="18288" anchor="t">
-                    <a:solidFill>
-                      <a:srgbClr val="FFFFFF"/>
-                    </a:solidFill>
-                  </a:tcPr>
-                </a:tc>
-                <a:tc>
-                  <a:txBody>
-                    <a:bodyPr wrap="square"/>
-                    <a:lstStyle/>
-                    <a:p>
-                      <a:pPr>
-                        <a:spcAft>
-                          <a:spcPts val="0"/>
-                        </a:spcAft>
-                      </a:pPr>
-                      <a:r>
-                        <a:rPr sz="950" b="0">
-                          <a:solidFill>
-                            <a:srgbClr val="535F6B"/>
-                          </a:solidFill>
-                          <a:latin typeface="Segoe UI"/>
-                        </a:rPr>
-                        <a:t>docs/agile/response-to-feedback.md</a:t>
-                      </a:r>
-                    </a:p>
-                  </a:txBody>
-                  <a:tcPr marL="64008" marR="45720" marT="18288" marB="18288" anchor="t">
-                    <a:solidFill>
-                      <a:srgbClr val="FFFFFF"/>
                     </a:solidFill>
                   </a:tcPr>
                 </a:tc>
@@ -7246,7 +7163,7 @@
                 </a:solidFill>
                 <a:latin typeface="Segoe UI"/>
               </a:rPr>
-              <a:t>•  The tests: tests/test-plan.md — criteria (3), scenarios (4), the execution record (5), defects and limitations (6) — and the runs in tests/evidence/, including the three records of 2026-10-15.</a:t>
+              <a:t>•  The tests: tests/test-plan.md — criteria (3), scenarios (4), the execution record (5), defects and limitations (6) — and the runs in tests/evidence/, including the four records of 2026-10-15.</a:t>
             </a:r>
           </a:p>
           <a:p>
@@ -9445,7 +9362,7 @@
         <p:spPr>
           <a:xfrm>
             <a:off x="685800" y="3886200"/>
-            <a:ext cx="10789920" cy="2440420"/>
+            <a:ext cx="10789920" cy="2399853"/>
           </a:xfrm>
           <a:prstGeom prst="rect">
             <a:avLst/>
@@ -10176,7 +10093,7 @@
                 </a:solidFill>
                 <a:latin typeface="Segoe UI"/>
               </a:rPr>
-              <a:t>•  Still open and recorded, not hidden: one condition sits on an activity's only outgoing flow (DEF-14), so it is documentation of intent rather than a guard, and no user is authenticated (DEF-07) or has submitted a form (DEF-08).</a:t>
+              <a:t>•  Still open and recorded, not hidden: no user is authenticated (DEF-07) or has submitted a form (DEF-08); the separation of duties stays structural, and every document says so.</a:t>
             </a:r>
           </a:p>
         </p:txBody>

</xml_diff>